<commit_message>
Use Rocky Chen 51 Careers email and phone on the contact slide
Replace Helio Space contact details with rocky.chen@51careers.ai and (631) 704-4533.

Co-authored-by: anthonyleedu <anthonyleedu@users.noreply.github.com>
</commit_message>
<xml_diff>
--- a/51Careers_AI_Investor_Overview.pptx
+++ b/51Careers_AI_Investor_Overview.pptx
@@ -32890,7 +32890,7 @@
         <p:spPr>
           <a:xfrm>
             <a:off x="822960" y="2834640"/>
-            <a:ext cx="3392424" cy="1828800"/>
+            <a:ext cx="5175504" cy="1828800"/>
           </a:xfrm>
           <a:prstGeom prst="roundRect">
             <a:avLst>
@@ -32936,8 +32936,8 @@
         </p:nvSpPr>
         <p:spPr>
           <a:xfrm>
-            <a:off x="1024128" y="3035808"/>
-            <a:ext cx="2990088" cy="256032"/>
+            <a:off x="1078992" y="3035808"/>
+            <a:ext cx="4663440" cy="256032"/>
           </a:xfrm>
           <a:prstGeom prst="rect">
             <a:avLst/>
@@ -32971,21 +32971,21 @@
         </p:nvSpPr>
         <p:spPr>
           <a:xfrm>
-            <a:off x="1024128" y="3401568"/>
-            <a:ext cx="2990088" cy="1005840"/>
-          </a:xfrm>
-          <a:prstGeom prst="rect">
-            <a:avLst/>
-          </a:prstGeom>
-          <a:noFill/>
-        </p:spPr>
-        <p:txBody>
-          <a:bodyPr wrap="none" anchor="t"/>
-          <a:lstStyle/>
-          <a:p>
-            <a:pPr algn="l"/>
-            <a:r>
-              <a:rPr sz="1800" b="1" i="0">
+            <a:off x="1078992" y="3401568"/>
+            <a:ext cx="4663440" cy="1005840"/>
+          </a:xfrm>
+          <a:prstGeom prst="rect">
+            <a:avLst/>
+          </a:prstGeom>
+          <a:noFill/>
+        </p:spPr>
+        <p:txBody>
+          <a:bodyPr wrap="none" anchor="t"/>
+          <a:lstStyle/>
+          <a:p>
+            <a:pPr algn="l"/>
+            <a:r>
+              <a:rPr sz="2200" b="1" i="0">
                 <a:solidFill>
                   <a:srgbClr val="FFFFFF"/>
                 </a:solidFill>
@@ -32993,7 +32993,7 @@
                 <a:ea typeface="Garamond"/>
                 <a:cs typeface="Garamond"/>
               </a:rPr>
-              <a:t>rocky@helio.space</a:t>
+              <a:t>rocky.chen@51careers.ai</a:t>
             </a:r>
           </a:p>
         </p:txBody>
@@ -33006,8 +33006,8 @@
         </p:nvSpPr>
         <p:spPr>
           <a:xfrm>
-            <a:off x="4398264" y="2834640"/>
-            <a:ext cx="3392424" cy="1828800"/>
+            <a:off x="6190488" y="2834640"/>
+            <a:ext cx="5175504" cy="1828800"/>
           </a:xfrm>
           <a:prstGeom prst="roundRect">
             <a:avLst>
@@ -33053,8 +33053,8 @@
         </p:nvSpPr>
         <p:spPr>
           <a:xfrm>
-            <a:off x="4599432" y="3035808"/>
-            <a:ext cx="2990088" cy="256032"/>
+            <a:off x="6446520" y="3035808"/>
+            <a:ext cx="4663440" cy="256032"/>
           </a:xfrm>
           <a:prstGeom prst="rect">
             <a:avLst/>
@@ -33088,21 +33088,21 @@
         </p:nvSpPr>
         <p:spPr>
           <a:xfrm>
-            <a:off x="4599432" y="3401568"/>
-            <a:ext cx="2990088" cy="1005840"/>
-          </a:xfrm>
-          <a:prstGeom prst="rect">
-            <a:avLst/>
-          </a:prstGeom>
-          <a:noFill/>
-        </p:spPr>
-        <p:txBody>
-          <a:bodyPr wrap="none" anchor="t"/>
-          <a:lstStyle/>
-          <a:p>
-            <a:pPr algn="l"/>
-            <a:r>
-              <a:rPr sz="1800" b="1" i="0">
+            <a:off x="6446520" y="3401568"/>
+            <a:ext cx="4663440" cy="1005840"/>
+          </a:xfrm>
+          <a:prstGeom prst="rect">
+            <a:avLst/>
+          </a:prstGeom>
+          <a:noFill/>
+        </p:spPr>
+        <p:txBody>
+          <a:bodyPr wrap="none" anchor="t"/>
+          <a:lstStyle/>
+          <a:p>
+            <a:pPr algn="l"/>
+            <a:r>
+              <a:rPr sz="2200" b="1" i="0">
                 <a:solidFill>
                   <a:srgbClr val="FFFFFF"/>
                 </a:solidFill>
@@ -33110,7 +33110,7 @@
                 <a:ea typeface="Garamond"/>
                 <a:cs typeface="Garamond"/>
               </a:rPr>
-              <a:t>19921169641</a:t>
+              <a:t>(631) 704-4533</a:t>
             </a:r>
           </a:p>
         </p:txBody>
@@ -33123,8 +33123,8 @@
         </p:nvSpPr>
         <p:spPr>
           <a:xfrm>
-            <a:off x="7973568" y="2834640"/>
-            <a:ext cx="3392424" cy="1828800"/>
+            <a:off x="822960" y="4828032"/>
+            <a:ext cx="10543032" cy="1207008"/>
           </a:xfrm>
           <a:prstGeom prst="roundRect">
             <a:avLst>
@@ -33170,123 +33170,6 @@
         </p:nvSpPr>
         <p:spPr>
           <a:xfrm>
-            <a:off x="8174736" y="3035808"/>
-            <a:ext cx="2990088" cy="256032"/>
-          </a:xfrm>
-          <a:prstGeom prst="rect">
-            <a:avLst/>
-          </a:prstGeom>
-          <a:noFill/>
-        </p:spPr>
-        <p:txBody>
-          <a:bodyPr wrap="none" anchor="t"/>
-          <a:lstStyle/>
-          <a:p>
-            <a:pPr algn="l"/>
-            <a:r>
-              <a:rPr sz="1200" b="1" i="0">
-                <a:solidFill>
-                  <a:srgbClr val="6FBCE8"/>
-                </a:solidFill>
-                <a:latin typeface="Garamond"/>
-                <a:ea typeface="Garamond"/>
-                <a:cs typeface="Garamond"/>
-              </a:rPr>
-              <a:t>WEB</a:t>
-            </a:r>
-          </a:p>
-        </p:txBody>
-      </p:sp>
-      <p:sp>
-        <p:nvSpPr>
-          <p:cNvPr id="15" name="TextBox 14"/>
-          <p:cNvSpPr txBox="1"/>
-          <p:nvPr/>
-        </p:nvSpPr>
-        <p:spPr>
-          <a:xfrm>
-            <a:off x="8174736" y="3401568"/>
-            <a:ext cx="2990088" cy="1005840"/>
-          </a:xfrm>
-          <a:prstGeom prst="rect">
-            <a:avLst/>
-          </a:prstGeom>
-          <a:noFill/>
-        </p:spPr>
-        <p:txBody>
-          <a:bodyPr wrap="none" anchor="t"/>
-          <a:lstStyle/>
-          <a:p>
-            <a:pPr algn="l"/>
-            <a:r>
-              <a:rPr sz="1800" b="1" i="0">
-                <a:solidFill>
-                  <a:srgbClr val="FFFFFF"/>
-                </a:solidFill>
-                <a:latin typeface="Garamond"/>
-                <a:ea typeface="Garamond"/>
-                <a:cs typeface="Garamond"/>
-              </a:rPr>
-              <a:t>www.helio.space</a:t>
-            </a:r>
-          </a:p>
-        </p:txBody>
-      </p:sp>
-      <p:sp>
-        <p:nvSpPr>
-          <p:cNvPr id="16" name="Rounded Rectangle 15"/>
-          <p:cNvSpPr/>
-          <p:nvPr/>
-        </p:nvSpPr>
-        <p:spPr>
-          <a:xfrm>
-            <a:off x="822960" y="4828032"/>
-            <a:ext cx="10543032" cy="1207008"/>
-          </a:xfrm>
-          <a:prstGeom prst="roundRect">
-            <a:avLst>
-              <a:gd name="adj" fmla="val 4000"/>
-            </a:avLst>
-          </a:prstGeom>
-          <a:solidFill>
-            <a:srgbClr val="0E2233"/>
-          </a:solidFill>
-          <a:ln w="9525">
-            <a:solidFill>
-              <a:srgbClr val="3C5A72"/>
-            </a:solidFill>
-          </a:ln>
-        </p:spPr>
-        <p:style>
-          <a:lnRef idx="1">
-            <a:schemeClr val="accent1"/>
-          </a:lnRef>
-          <a:fillRef idx="3">
-            <a:schemeClr val="accent1"/>
-          </a:fillRef>
-          <a:effectRef idx="2">
-            <a:schemeClr val="accent1"/>
-          </a:effectRef>
-          <a:fontRef idx="minor">
-            <a:schemeClr val="lt1"/>
-          </a:fontRef>
-        </p:style>
-        <p:txBody>
-          <a:bodyPr rtlCol="0" anchor="ctr"/>
-          <a:lstStyle/>
-          <a:p>
-            <a:pPr algn="ctr"/>
-          </a:p>
-        </p:txBody>
-      </p:sp>
-      <p:sp>
-        <p:nvSpPr>
-          <p:cNvPr id="17" name="TextBox 16"/>
-          <p:cNvSpPr txBox="1"/>
-          <p:nvPr/>
-        </p:nvSpPr>
-        <p:spPr>
-          <a:xfrm>
             <a:off x="1024128" y="4974336"/>
             <a:ext cx="10140696" cy="329184"/>
           </a:xfrm>
@@ -33316,7 +33199,7 @@
       </p:sp>
       <p:sp>
         <p:nvSpPr>
-          <p:cNvPr id="18" name="TextBox 17"/>
+          <p:cNvPr id="15" name="TextBox 14"/>
           <p:cNvSpPr txBox="1"/>
           <p:nvPr/>
         </p:nvSpPr>
@@ -33344,14 +33227,14 @@
                 <a:ea typeface="Garamond"/>
                 <a:cs typeface="Garamond"/>
               </a:rPr>
-              <a:t>info@helio.space   ·   (510) 545-2666   ·   2448 Sixth Street, Berkeley, CA 94710</a:t>
-            </a:r>
-          </a:p>
-        </p:txBody>
-      </p:sp>
-      <p:sp>
-        <p:nvSpPr>
-          <p:cNvPr id="19" name="TextBox 18"/>
+              <a:t>rocky.chen@51careers.ai   ·   (631) 704-4533</a:t>
+            </a:r>
+          </a:p>
+        </p:txBody>
+      </p:sp>
+      <p:sp>
+        <p:nvSpPr>
+          <p:cNvPr id="16" name="TextBox 15"/>
           <p:cNvSpPr txBox="1"/>
           <p:nvPr/>
         </p:nvSpPr>

</xml_diff>

<commit_message>
Use rocky.chen@51careers.com on the contact slide
Co-authored-by: anthonyleedu <anthonyleedu@users.noreply.github.com>
</commit_message>
<xml_diff>
--- a/51Careers_AI_Investor_Overview.pptx
+++ b/51Careers_AI_Investor_Overview.pptx
@@ -32993,7 +32993,7 @@
                 <a:ea typeface="Garamond"/>
                 <a:cs typeface="Garamond"/>
               </a:rPr>
-              <a:t>rocky.chen@51careers.ai</a:t>
+              <a:t>rocky.chen@51careers.com</a:t>
             </a:r>
           </a:p>
         </p:txBody>
@@ -33227,7 +33227,7 @@
                 <a:ea typeface="Garamond"/>
                 <a:cs typeface="Garamond"/>
               </a:rPr>
-              <a:t>rocky.chen@51careers.ai   ·   (631) 704-4533</a:t>
+              <a:t>rocky.chen@51careers.com   ·   (631) 704-4533</a:t>
             </a:r>
           </a:p>
         </p:txBody>

</xml_diff>